<commit_message>
Add evidence-gated PG adjacency scenario
</commit_message>
<xml_diff>
--- a/Flipkart_Minutes_WiRED_SemiFinal_FULL_light.pptx
+++ b/Flipkart_Minutes_WiRED_SemiFinal_FULL_light.pptx
@@ -4261,7 +4261,7 @@
                 </a:solidFill>
                 <a:latin typeface="Calibri"/>
               </a:rPr>
-              <a:t>366</a:t>
+              <a:t>378</a:t>
             </a:r>
           </a:p>
         </p:txBody>
@@ -4732,7 +4732,7 @@
                 </a:solidFill>
                 <a:latin typeface="Calibri"/>
               </a:rPr>
-              <a:t>183</a:t>
+              <a:t>184</a:t>
             </a:r>
           </a:p>
         </p:txBody>
@@ -4889,7 +4889,7 @@
                 </a:solidFill>
                 <a:latin typeface="Calibri"/>
               </a:rPr>
-              <a:t>23</a:t>
+              <a:t>28</a:t>
             </a:r>
           </a:p>
         </p:txBody>
@@ -5272,7 +5272,7 @@
                 </a:solidFill>
                 <a:latin typeface="Calibri"/>
               </a:rPr>
-              <a:t>audit.py — the model checked against itself, 366 assertions</a:t>
+              <a:t>audit.py — the model checked against itself, 378 assertions</a:t>
             </a:r>
           </a:p>
         </p:txBody>
@@ -5423,7 +5423,7 @@
                 </a:solidFill>
                 <a:latin typeface="Calibri"/>
               </a:rPr>
-              <a:t>366 / 366</a:t>
+              <a:t>378 / 378</a:t>
             </a:r>
           </a:p>
         </p:txBody>
@@ -5580,7 +5580,7 @@
                 </a:solidFill>
                 <a:latin typeface="Calibri"/>
               </a:rPr>
-              <a:t>183 / 183</a:t>
+              <a:t>184 / 184</a:t>
             </a:r>
           </a:p>
         </p:txBody>
@@ -5981,7 +5981,7 @@
                 </a:solidFill>
                 <a:latin typeface="Consolas"/>
               </a:rPr>
-              <a:t>  audit.py                  366 / 366   model vs itself</a:t>
+              <a:t>  audit.py                  378 / 378   model vs itself</a:t>
             </a:r>
           </a:p>
           <a:p>
@@ -6029,7 +6029,7 @@
                 </a:solidFill>
                 <a:latin typeface="Consolas"/>
               </a:rPr>
-              <a:t>  verify_deck.py            183 / 183   built slides vs model</a:t>
+              <a:t>  verify_deck.py            184 / 184   built slides vs model</a:t>
             </a:r>
           </a:p>
           <a:p>
@@ -6045,7 +6045,7 @@
                 </a:solidFill>
                 <a:latin typeface="Consolas"/>
               </a:rPr>
-              <a:t>  verify_artifacts.py         23 / 23   workbook, notebooks, manifest</a:t>
+              <a:t>  verify_artifacts.py         28 / 28   workbook, notebooks, manifest</a:t>
             </a:r>
           </a:p>
           <a:p>
@@ -20257,7 +20257,7 @@
                 </a:solidFill>
                 <a:latin typeface="Calibri"/>
               </a:rPr>
-              <a:t>PGs sit tighter to campus than a standard zone, so they are geometrically CHEAPER to reach than the benchmark. What is missing is demand evidence: the AISHE register carries no PG count, so density is unmeasured, and whether a given block supports a common drop is a site question. PGs are therefore a Phase-2 adjacency, subject to pilot validation of density and common-drop feasibility.</a:t>
+              <a:t>PGs sit tighter to campus than a standard zone, so they are geometrically CHEAPER to reach than the benchmark. What is missing is demand evidence: the AISHE register carries no PG count, so density is unmeasured, and whether a given block supports a common drop is a site question. PGs are therefore a Phase-2 adjacency, subject to common-drop feasibility. The evidence-gated scenario in pg_demand.py and workbook tab 9 admits them only into spare term capacity or measured break-period capacity.</a:t>
             </a:r>
           </a:p>
         </p:txBody>
@@ -20381,7 +20381,7 @@
                 </a:solidFill>
                 <a:latin typeface="Calibri"/>
               </a:rPr>
-              <a:t>Every figure on this page is computed by cost_stack.segment_cpo() and sla.cost_legs(), and asserted in audit.py. None of it is typed.</a:t>
+              <a:t>Every figure on this page is computed by cost_stack.segment_cpo(), sla.cost_legs() and pg_demand.py, and asserted in audit.py. None of it is typed.</a:t>
             </a:r>
           </a:p>
         </p:txBody>

</xml_diff>